<commit_message>
slides: add source-vs-client slide; list Q9b/Q9c in "See it live"
Section 2's slides now have a dedicated "Source view vs. client view"
slide between the downstream-tabs slide and the endpoint.name slide.
It calls out that the source-view split is available today (not
aspirational) via postgres-exporter + otel-postgres for Postgres and
OneAgent's built-in sensor for Apache Kafka — closing the gap between
what the lecture slides describe and what the notebook now actually
demonstrates live.

Also updated the final "See it live" slide's demo bullets to list
Q9b (Postgres source-vs-client) and Q9c (Kafka source-vs-client)
explicitly, so the printed deck matches the notebook's current
question set.

PPTX rebuilt (339660 bytes).

Co-Authored-By: Claude Opus 4.7 (1M context) <noreply@anthropic.com>
</commit_message>
<xml_diff>
--- a/presentation/sdv2-presentation.pptx
+++ b/presentation/sdv2-presentation.pptx
@@ -26,9 +26,10 @@
     <p:sldId id="274" r:id="rId20"/>
     <p:sldId id="275" r:id="rId21"/>
     <p:sldId id="276" r:id="rId22"/>
+    <p:sldId id="277" r:id="rId23"/>
   </p:sldIdLst>
   <p:notesMasterIdLst>
-    <p:notesMasterId r:id="rId23"/>
+    <p:notesMasterId r:id="rId24"/>
   </p:notesMasterIdLst>
   <p:sldSz cx="9144000" cy="5143500"/>
   <p:notesSz cx="5143500" cy="9144000"/>
@@ -1690,6 +1691,94 @@
             <a:fld id="{F7021451-1387-4CA6-816F-3879F97B5CBC}" type="slidenum">
               <a:rPr lang="en-US"/>
               <a:t>21</a:t>
+            </a:fld>
+            <a:endParaRPr lang="en-US"/>
+          </a:p>
+        </p:txBody>
+      </p:sp>
+    </p:spTree>
+    <p:extLst>
+      <p:ext uri="{BB962C8B-B14F-4D97-AF65-F5344CB8AC3E}">
+        <p14:creationId xmlns:p14="http://schemas.microsoft.com/office/powerpoint/2010/main" val="1024086991"/>
+      </p:ext>
+    </p:extLst>
+  </p:cSld>
+  <p:clrMapOvr>
+    <a:masterClrMapping/>
+  </p:clrMapOvr>
+</p:notes>
+</file>
+
+<file path=ppt/notesSlides/notesSlide22.xml><?xml version="1.0" encoding="utf-8"?>
+<p:notes xmlns:a="http://schemas.openxmlformats.org/drawingml/2006/main" xmlns:r="http://schemas.openxmlformats.org/officeDocument/2006/relationships" xmlns:p="http://schemas.openxmlformats.org/presentationml/2006/main">
+  <p:cSld>
+    <p:spTree>
+      <p:nvGrpSpPr>
+        <p:cNvPr id="1" name=""/>
+        <p:cNvGrpSpPr/>
+        <p:nvPr/>
+      </p:nvGrpSpPr>
+      <p:grpSpPr>
+        <a:xfrm>
+          <a:off x="0" y="0"/>
+          <a:ext cx="0" cy="0"/>
+          <a:chOff x="0" y="0"/>
+          <a:chExt cx="0" cy="0"/>
+        </a:xfrm>
+      </p:grpSpPr>
+      <p:sp>
+        <p:nvSpPr>
+          <p:cNvPr id="2" name="Slide Image Placeholder 1"/>
+          <p:cNvSpPr>
+            <a:spLocks noGrp="1" noRot="1" noChangeAspect="1"/>
+          </p:cNvSpPr>
+          <p:nvPr>
+            <p:ph type="sldImg"/>
+          </p:nvPr>
+        </p:nvSpPr>
+        <p:spPr/>
+      </p:sp>
+      <p:sp>
+        <p:nvSpPr>
+          <p:cNvPr id="3" name="Notes Placeholder 2"/>
+          <p:cNvSpPr>
+            <a:spLocks noGrp="1"/>
+          </p:cNvSpPr>
+          <p:nvPr>
+            <p:ph type="body" idx="1"/>
+          </p:nvPr>
+        </p:nvSpPr>
+        <p:spPr/>
+        <p:txBody>
+          <a:bodyPr/>
+          <a:lstStyle/>
+          <a:p>
+            <a:r>
+              <a:rPr lang="en-US" dirty="0"/>
+              <a:t/>
+            </a:r>
+            <a:endParaRPr lang="en-US" dirty="0"/>
+          </a:p>
+        </p:txBody>
+      </p:sp>
+      <p:sp>
+        <p:nvSpPr>
+          <p:cNvPr id="4" name="Slide Number Placeholder 3"/>
+          <p:cNvSpPr>
+            <a:spLocks noGrp="1"/>
+          </p:cNvSpPr>
+          <p:nvPr>
+            <p:ph type="sldNum" sz="quarter" idx="10"/>
+          </p:nvPr>
+        </p:nvSpPr>
+        <p:spPr/>
+        <p:txBody>
+          <a:bodyPr/>
+          <a:lstStyle/>
+          <a:p>
+            <a:fld id="{F7021451-1387-4CA6-816F-3879F97B5CBC}" type="slidenum">
+              <a:rPr lang="en-US"/>
+              <a:t>22</a:t>
             </a:fld>
             <a:endParaRPr lang="en-US"/>
           </a:p>
@@ -6675,7 +6764,7 @@
         <p:spPr>
           <a:xfrm>
             <a:off x="457200" y="457200"/>
-            <a:ext cx="8229600" cy="640080"/>
+            <a:ext cx="8229600" cy="914400"/>
           </a:xfrm>
           <a:prstGeom prst="rect">
             <a:avLst/>
@@ -6699,7 +6788,7 @@
                 <a:ea typeface="Segoe UI" pitchFamily="34" charset="-122"/>
                 <a:cs typeface="Segoe UI" pitchFamily="34" charset="-120"/>
               </a:rPr>
-              <a:t>`endpoint.name` and the `GET /*` reality</a:t>
+              <a:t>Source view vs. client view — already possible today</a:t>
             </a:r>
             <a:endParaRPr lang="en-US" sz="3600" dirty="0"/>
           </a:p>
@@ -6713,7 +6802,7 @@
         </p:nvSpPr>
         <p:spPr>
           <a:xfrm>
-            <a:off x="457200" y="1188720"/>
+            <a:off x="457200" y="1463040"/>
             <a:ext cx="4114800" cy="54864"/>
           </a:xfrm>
           <a:prstGeom prst="rect">
@@ -6738,7 +6827,7 @@
         </p:nvSpPr>
         <p:spPr>
           <a:xfrm>
-            <a:off x="4572000" y="1188720"/>
+            <a:off x="4572000" y="1463040"/>
             <a:ext cx="4114800" cy="54864"/>
           </a:xfrm>
           <a:prstGeom prst="rect">
@@ -6763,8 +6852,8 @@
         </p:nvSpPr>
         <p:spPr>
           <a:xfrm>
-            <a:off x="457200" y="1463040"/>
-            <a:ext cx="8229600" cy="1691640"/>
+            <a:off x="457200" y="1737360"/>
+            <a:ext cx="8229600" cy="1527048"/>
           </a:xfrm>
           <a:prstGeom prst="rect">
             <a:avLst/>
@@ -6776,12 +6865,8 @@
           <a:bodyPr wrap="square" lIns="0" tIns="0" rIns="0" bIns="0" rtlCol="0" anchor="t"/>
           <a:lstStyle/>
           <a:p>
-            <a:pPr marL="342900" indent="-342900">
-              <a:lnSpc>
-                <a:spcPct val="120000"/>
-              </a:lnSpc>
-              <a:buSzPct val="100000"/>
-              <a:buChar char="•"/>
+            <a:pPr indent="0" marL="0">
+              <a:buNone/>
             </a:pPr>
             <a:r>
               <a:rPr lang="en-US" sz="2000" dirty="0">
@@ -6792,38 +6877,24 @@
                 <a:ea typeface="Segoe UI" pitchFamily="34" charset="-122"/>
                 <a:cs typeface="Segoe UI" pitchFamily="34" charset="-120"/>
               </a:rPr>
-              <a:t>endpoint.name derives from http.route on server spans</a:t>
-            </a:r>
-            <a:endParaRPr lang="en-US" sz="2000" dirty="0"/>
-          </a:p>
-          <a:p>
-            <a:pPr marL="342900" indent="-342900">
-              <a:lnSpc>
-                <a:spcPct val="120000"/>
-              </a:lnSpc>
-              <a:buSzPct val="100000"/>
-              <a:buChar char="•"/>
-            </a:pPr>
-            <a:r>
-              <a:rPr lang="en-US" sz="2000" dirty="0">
-                <a:solidFill>
-                  <a:srgbClr val="FFFFFF"/>
+              <a:t>You don't have to wait for SDv2-for-OneAgent's topology linking to </a:t>
+            </a:r>
+            <a:pPr indent="0" marL="0">
+              <a:buNone/>
+            </a:pPr>
+            <a:r>
+              <a:rPr lang="en-US" sz="2000" b="1" dirty="0">
+                <a:solidFill>
+                  <a:srgbClr val="00A1E0"/>
                 </a:solidFill>
                 <a:latin typeface="Segoe UI" pitchFamily="34" charset="0"/>
                 <a:ea typeface="Segoe UI" pitchFamily="34" charset="-122"/>
                 <a:cs typeface="Segoe UI" pitchFamily="34" charset="-120"/>
               </a:rPr>
-              <a:t>If http.route isn't set → fallback to &lt;METHOD&gt; /*</a:t>
-            </a:r>
-            <a:endParaRPr lang="en-US" sz="2000" dirty="0"/>
-          </a:p>
-          <a:p>
-            <a:pPr marL="342900" indent="-342900">
-              <a:lnSpc>
-                <a:spcPct val="120000"/>
-              </a:lnSpc>
-              <a:buSzPct val="100000"/>
-              <a:buChar char="•"/>
+              <a:t>see</a:t>
+            </a:r>
+            <a:pPr indent="0" marL="0">
+              <a:buNone/>
             </a:pPr>
             <a:r>
               <a:rPr lang="en-US" sz="2000" dirty="0">
@@ -6834,167 +6905,661 @@
                 <a:ea typeface="Segoe UI" pitchFamily="34" charset="-122"/>
                 <a:cs typeface="Segoe UI" pitchFamily="34" charset="-120"/>
               </a:rPr>
-              <a:t>Spring MVC + OneAgent + orders-demo today → every endpoint is GET /*</a:t>
+              <a:t> the source-vs-client split. Stand up a standard Prometheus exporter or use a OneAgent built-in sensor, and the "real entity" view exists alongside the client-span view right now.</a:t>
             </a:r>
             <a:endParaRPr lang="en-US" sz="2000" dirty="0"/>
           </a:p>
-          <a:p>
-            <a:pPr marL="342900" indent="-342900">
-              <a:lnSpc>
-                <a:spcPct val="120000"/>
-              </a:lnSpc>
-              <a:buSzPct val="100000"/>
-              <a:buChar char="•"/>
-            </a:pPr>
-            <a:r>
-              <a:rPr lang="en-US" sz="2000" dirty="0">
-                <a:solidFill>
-                  <a:srgbClr val="FFFFFF"/>
-                </a:solidFill>
-                <a:latin typeface="Segoe UI" pitchFamily="34" charset="0"/>
-                <a:ea typeface="Segoe UI" pitchFamily="34" charset="-122"/>
-                <a:cs typeface="Segoe UI" pitchFamily="34" charset="-120"/>
-              </a:rPr>
-              <a:t>Throughput and latency are still right. The labels are wrong.</a:t>
-            </a:r>
-            <a:endParaRPr lang="en-US" sz="2000" dirty="0"/>
-          </a:p>
         </p:txBody>
       </p:sp>
-      <p:sp>
-        <p:nvSpPr>
-          <p:cNvPr id="6" name="Text 4"/>
-          <p:cNvSpPr/>
-          <p:nvPr/>
-        </p:nvSpPr>
-        <p:spPr>
-          <a:xfrm>
-            <a:off x="457200" y="3291840"/>
-            <a:ext cx="8229600" cy="832104"/>
-          </a:xfrm>
-          <a:prstGeom prst="rect">
-            <a:avLst/>
-          </a:prstGeom>
-          <a:noFill/>
-          <a:ln/>
-        </p:spPr>
-        <p:txBody>
-          <a:bodyPr wrap="square" lIns="0" tIns="0" rIns="0" bIns="0" rtlCol="0" anchor="t"/>
-          <a:lstStyle/>
-          <a:p>
-            <a:pPr indent="0" marL="0">
-              <a:buNone/>
-            </a:pPr>
-            <a:r>
-              <a:rPr lang="en-US" sz="2000" b="1" dirty="0">
-                <a:solidFill>
-                  <a:srgbClr val="00A1E0"/>
-                </a:solidFill>
-                <a:latin typeface="Segoe UI" pitchFamily="34" charset="0"/>
-                <a:ea typeface="Segoe UI" pitchFamily="34" charset="-122"/>
-                <a:cs typeface="Segoe UI" pitchFamily="34" charset="-120"/>
-              </a:rPr>
-              <a:t>Fix today:</a:t>
-            </a:r>
-            <a:pPr indent="0" marL="0">
-              <a:buNone/>
-            </a:pPr>
-            <a:r>
-              <a:rPr lang="en-US" sz="2000" dirty="0">
-                <a:solidFill>
-                  <a:srgbClr val="FFFFFF"/>
-                </a:solidFill>
-                <a:latin typeface="Segoe UI" pitchFamily="34" charset="0"/>
-                <a:ea typeface="Segoe UI" pitchFamily="34" charset="-122"/>
-                <a:cs typeface="Segoe UI" pitchFamily="34" charset="-120"/>
-              </a:rPr>
-              <a:t> Settings → Service detection → URL path pattern matching (SDv1 and SDv2).</a:t>
-            </a:r>
-            <a:endParaRPr lang="en-US" sz="2000" dirty="0"/>
-          </a:p>
-        </p:txBody>
-      </p:sp>
-      <p:sp>
-        <p:nvSpPr>
-          <p:cNvPr id="7" name="Text 5"/>
-          <p:cNvSpPr/>
-          <p:nvPr/>
-        </p:nvSpPr>
-        <p:spPr>
-          <a:xfrm>
-            <a:off x="457200" y="4306824"/>
-            <a:ext cx="8229600" cy="448056"/>
-          </a:xfrm>
-          <a:prstGeom prst="rect">
-            <a:avLst/>
-          </a:prstGeom>
-          <a:noFill/>
-          <a:ln/>
-        </p:spPr>
-        <p:txBody>
-          <a:bodyPr wrap="square" lIns="0" tIns="0" rIns="0" bIns="0" rtlCol="0" anchor="t"/>
-          <a:lstStyle/>
-          <a:p>
-            <a:pPr indent="0" marL="0">
-              <a:buNone/>
-            </a:pPr>
-            <a:r>
-              <a:rPr lang="en-US" sz="2000" b="1" dirty="0">
-                <a:solidFill>
-                  <a:srgbClr val="00A1E0"/>
-                </a:solidFill>
-                <a:latin typeface="Segoe UI" pitchFamily="34" charset="0"/>
-                <a:ea typeface="Segoe UI" pitchFamily="34" charset="-122"/>
-                <a:cs typeface="Segoe UI" pitchFamily="34" charset="-120"/>
-              </a:rPr>
-              <a:t>Automatic URL normalization coming.</a:t>
-            </a:r>
-            <a:pPr indent="0" marL="0">
-              <a:buNone/>
-            </a:pPr>
-            <a:r>
-              <a:rPr lang="en-US" sz="2000" dirty="0">
-                <a:solidFill>
-                  <a:srgbClr val="FFFFFF"/>
-                </a:solidFill>
-                <a:latin typeface="Segoe UI" pitchFamily="34" charset="0"/>
-                <a:ea typeface="Segoe UI" pitchFamily="34" charset="-122"/>
-                <a:cs typeface="Segoe UI" pitchFamily="34" charset="-120"/>
-              </a:rPr>
-              <a:t> Derives </a:t>
-            </a:r>
-            <a:pPr indent="0" marL="0">
-              <a:buNone/>
-            </a:pPr>
-            <a:r>
-              <a:rPr lang="en-US" sz="1800" dirty="0">
-                <a:solidFill>
-                  <a:srgbClr val="FFFFFF"/>
-                </a:solidFill>
-                <a:latin typeface="Consolas" pitchFamily="34" charset="0"/>
-                <a:ea typeface="Consolas" pitchFamily="34" charset="-122"/>
-                <a:cs typeface="Consolas" pitchFamily="34" charset="-120"/>
-              </a:rPr>
-              <a:t>http.route</a:t>
-            </a:r>
-            <a:pPr indent="0" marL="0">
-              <a:buNone/>
-            </a:pPr>
-            <a:r>
-              <a:rPr lang="en-US" sz="2000" dirty="0">
-                <a:solidFill>
-                  <a:srgbClr val="FFFFFF"/>
-                </a:solidFill>
-                <a:latin typeface="Segoe UI" pitchFamily="34" charset="0"/>
-                <a:ea typeface="Segoe UI" pitchFamily="34" charset="-122"/>
-                <a:cs typeface="Segoe UI" pitchFamily="34" charset="-120"/>
-              </a:rPr>
-              <a:t> by truncating at the first volatile segment (IDs, hashes, UUIDs). Classic-first rollout; SDv2 opt-in then default.</a:t>
-            </a:r>
-            <a:endParaRPr lang="en-US" sz="2000" dirty="0"/>
-          </a:p>
-        </p:txBody>
-      </p:sp>
+      <p:graphicFrame>
+        <p:nvGraphicFramePr>
+          <p:cNvPr id="18" name="Table 0"/>
+          <p:cNvGraphicFramePr>
+            <a:graphicFrameLocks noGrp="1"/>
+          </p:cNvGraphicFramePr>
+          <p:nvPr>
+            <p:extLst>
+              <p:ext uri="{D42A27DB-BD31-4B8C-83A1-F6EECF244321}">
+                <p14:modId xmlns:p14="http://schemas.microsoft.com/office/powerpoint/2010/main" val="1579011935"/>
+              </p:ext>
+            </p:extLst>
+          </p:nvPr>
+        </p:nvGraphicFramePr>
+        <p:xfrm>
+          <a:off x="457200" y="3447288"/>
+          <a:ext cx="8229600" cy="914400"/>
+        </p:xfrm>
+        <a:graphic>
+          <a:graphicData uri="http://schemas.openxmlformats.org/drawingml/2006/table">
+            <a:tbl>
+              <a:tblPr/>
+              <a:tblGrid>
+                <a:gridCol w="1016337"/>
+                <a:gridCol w="3632211"/>
+                <a:gridCol w="3581053"/>
+              </a:tblGrid>
+              <a:tr h="786384">
+                <a:tc>
+                  <a:txBody>
+                    <a:bodyPr/>
+                    <a:lstStyle/>
+                    <a:p>
+                      <a:pPr indent="0" marL="0">
+                        <a:buNone/>
+                      </a:pPr>
+                      <a:r>
+                        <a:rPr lang="en-US" sz="1200" b="1" dirty="0">
+                          <a:solidFill>
+                            <a:srgbClr val="FFFFFF"/>
+                          </a:solidFill>
+                          <a:latin typeface="Segoe UI" pitchFamily="34" charset="0"/>
+                          <a:ea typeface="Segoe UI" pitchFamily="34" charset="-122"/>
+                          <a:cs typeface="Segoe UI" pitchFamily="34" charset="-120"/>
+                        </a:rPr>
+                        <a:t>Target</a:t>
+                      </a:r>
+                      <a:endParaRPr lang="en-US" sz="1200" dirty="0">
+                        <a:latin typeface="Segoe UI" charset="0"/>
+                        <a:ea typeface="Segoe UI" charset="0"/>
+                        <a:cs typeface="Segoe UI" charset="0"/>
+                      </a:endParaRPr>
+                    </a:p>
+                  </a:txBody>
+                  <a:tcPr marL="91440" marR="91440" marT="45720" marB="45720" anchor="ctr">
+                    <a:lnL w="0" cap="flat" cmpd="sng" algn="ctr">
+                      <a:solidFill>
+                        <a:srgbClr val="0A0A14"/>
+                      </a:solidFill>
+                      <a:prstDash val="solid"/>
+                      <a:round/>
+                      <a:headEnd type="none" w="med" len="med"/>
+                      <a:tailEnd type="none" w="med" len="med"/>
+                    </a:lnL>
+                    <a:lnR w="0" cap="flat" cmpd="sng" algn="ctr">
+                      <a:solidFill>
+                        <a:srgbClr val="0A0A14"/>
+                      </a:solidFill>
+                      <a:prstDash val="solid"/>
+                      <a:round/>
+                      <a:headEnd type="none" w="med" len="med"/>
+                      <a:tailEnd type="none" w="med" len="med"/>
+                    </a:lnR>
+                    <a:lnT w="0" cap="flat" cmpd="sng" algn="ctr">
+                      <a:solidFill>
+                        <a:srgbClr val="0A0A14"/>
+                      </a:solidFill>
+                      <a:prstDash val="solid"/>
+                      <a:round/>
+                      <a:headEnd type="none" w="med" len="med"/>
+                      <a:tailEnd type="none" w="med" len="med"/>
+                    </a:lnT>
+                    <a:lnB w="12700" cap="flat" cmpd="sng" algn="ctr">
+                      <a:solidFill>
+                        <a:srgbClr val="2A2A3E"/>
+                      </a:solidFill>
+                      <a:prstDash val="solid"/>
+                      <a:round/>
+                      <a:headEnd type="none" w="med" len="med"/>
+                      <a:tailEnd type="none" w="med" len="med"/>
+                    </a:lnB>
+                    <a:solidFill>
+                      <a:srgbClr val="0A0A14"/>
+                    </a:solidFill>
+                  </a:tcPr>
+                </a:tc>
+                <a:tc>
+                  <a:txBody>
+                    <a:bodyPr/>
+                    <a:lstStyle/>
+                    <a:p>
+                      <a:pPr indent="0" marL="0">
+                        <a:buNone/>
+                      </a:pPr>
+                      <a:r>
+                        <a:rPr lang="en-US" sz="1200" b="1" dirty="0">
+                          <a:solidFill>
+                            <a:srgbClr val="FFFFFF"/>
+                          </a:solidFill>
+                          <a:latin typeface="Segoe UI" pitchFamily="34" charset="0"/>
+                          <a:ea typeface="Segoe UI" pitchFamily="34" charset="-122"/>
+                          <a:cs typeface="Segoe UI" pitchFamily="34" charset="-120"/>
+                        </a:rPr>
+                        <a:t>Source-view path today</a:t>
+                      </a:r>
+                      <a:endParaRPr lang="en-US" sz="1200" dirty="0">
+                        <a:latin typeface="Segoe UI" charset="0"/>
+                        <a:ea typeface="Segoe UI" charset="0"/>
+                        <a:cs typeface="Segoe UI" charset="0"/>
+                      </a:endParaRPr>
+                    </a:p>
+                  </a:txBody>
+                  <a:tcPr marL="91440" marR="91440" marT="45720" marB="45720" anchor="ctr">
+                    <a:lnL w="0" cap="flat" cmpd="sng" algn="ctr">
+                      <a:solidFill>
+                        <a:srgbClr val="0A0A14"/>
+                      </a:solidFill>
+                      <a:prstDash val="solid"/>
+                      <a:round/>
+                      <a:headEnd type="none" w="med" len="med"/>
+                      <a:tailEnd type="none" w="med" len="med"/>
+                    </a:lnL>
+                    <a:lnR w="0" cap="flat" cmpd="sng" algn="ctr">
+                      <a:solidFill>
+                        <a:srgbClr val="0A0A14"/>
+                      </a:solidFill>
+                      <a:prstDash val="solid"/>
+                      <a:round/>
+                      <a:headEnd type="none" w="med" len="med"/>
+                      <a:tailEnd type="none" w="med" len="med"/>
+                    </a:lnR>
+                    <a:lnT w="0" cap="flat" cmpd="sng" algn="ctr">
+                      <a:solidFill>
+                        <a:srgbClr val="0A0A14"/>
+                      </a:solidFill>
+                      <a:prstDash val="solid"/>
+                      <a:round/>
+                      <a:headEnd type="none" w="med" len="med"/>
+                      <a:tailEnd type="none" w="med" len="med"/>
+                    </a:lnT>
+                    <a:lnB w="12700" cap="flat" cmpd="sng" algn="ctr">
+                      <a:solidFill>
+                        <a:srgbClr val="2A2A3E"/>
+                      </a:solidFill>
+                      <a:prstDash val="solid"/>
+                      <a:round/>
+                      <a:headEnd type="none" w="med" len="med"/>
+                      <a:tailEnd type="none" w="med" len="med"/>
+                    </a:lnB>
+                    <a:solidFill>
+                      <a:srgbClr val="0A0A14"/>
+                    </a:solidFill>
+                  </a:tcPr>
+                </a:tc>
+                <a:tc>
+                  <a:txBody>
+                    <a:bodyPr/>
+                    <a:lstStyle/>
+                    <a:p>
+                      <a:pPr indent="0" marL="0">
+                        <a:buNone/>
+                      </a:pPr>
+                      <a:r>
+                        <a:rPr lang="en-US" sz="1200" b="1" dirty="0">
+                          <a:solidFill>
+                            <a:srgbClr val="FFFFFF"/>
+                          </a:solidFill>
+                          <a:latin typeface="Segoe UI" pitchFamily="34" charset="0"/>
+                          <a:ea typeface="Segoe UI" pitchFamily="34" charset="-122"/>
+                          <a:cs typeface="Segoe UI" pitchFamily="34" charset="-120"/>
+                        </a:rPr>
+                        <a:t>Example metrics</a:t>
+                      </a:r>
+                      <a:endParaRPr lang="en-US" sz="1200" dirty="0">
+                        <a:latin typeface="Segoe UI" charset="0"/>
+                        <a:ea typeface="Segoe UI" charset="0"/>
+                        <a:cs typeface="Segoe UI" charset="0"/>
+                      </a:endParaRPr>
+                    </a:p>
+                  </a:txBody>
+                  <a:tcPr marL="91440" marR="91440" marT="45720" marB="45720" anchor="ctr">
+                    <a:lnL w="0" cap="flat" cmpd="sng" algn="ctr">
+                      <a:solidFill>
+                        <a:srgbClr val="0A0A14"/>
+                      </a:solidFill>
+                      <a:prstDash val="solid"/>
+                      <a:round/>
+                      <a:headEnd type="none" w="med" len="med"/>
+                      <a:tailEnd type="none" w="med" len="med"/>
+                    </a:lnL>
+                    <a:lnR w="0" cap="flat" cmpd="sng" algn="ctr">
+                      <a:solidFill>
+                        <a:srgbClr val="0A0A14"/>
+                      </a:solidFill>
+                      <a:prstDash val="solid"/>
+                      <a:round/>
+                      <a:headEnd type="none" w="med" len="med"/>
+                      <a:tailEnd type="none" w="med" len="med"/>
+                    </a:lnR>
+                    <a:lnT w="0" cap="flat" cmpd="sng" algn="ctr">
+                      <a:solidFill>
+                        <a:srgbClr val="0A0A14"/>
+                      </a:solidFill>
+                      <a:prstDash val="solid"/>
+                      <a:round/>
+                      <a:headEnd type="none" w="med" len="med"/>
+                      <a:tailEnd type="none" w="med" len="med"/>
+                    </a:lnT>
+                    <a:lnB w="12700" cap="flat" cmpd="sng" algn="ctr">
+                      <a:solidFill>
+                        <a:srgbClr val="2A2A3E"/>
+                      </a:solidFill>
+                      <a:prstDash val="solid"/>
+                      <a:round/>
+                      <a:headEnd type="none" w="med" len="med"/>
+                      <a:tailEnd type="none" w="med" len="med"/>
+                    </a:lnB>
+                    <a:solidFill>
+                      <a:srgbClr val="0A0A14"/>
+                    </a:solidFill>
+                  </a:tcPr>
+                </a:tc>
+              </a:tr>
+              <a:tr h="786384">
+                <a:tc>
+                  <a:txBody>
+                    <a:bodyPr/>
+                    <a:lstStyle/>
+                    <a:p>
+                      <a:pPr indent="0" marL="0">
+                        <a:buNone/>
+                      </a:pPr>
+                      <a:r>
+                        <a:rPr lang="en-US" sz="1200" dirty="0">
+                          <a:solidFill>
+                            <a:srgbClr val="FFFFFF"/>
+                          </a:solidFill>
+                          <a:latin typeface="Segoe UI" pitchFamily="34" charset="0"/>
+                          <a:ea typeface="Segoe UI" pitchFamily="34" charset="-122"/>
+                          <a:cs typeface="Segoe UI" pitchFamily="34" charset="-120"/>
+                        </a:rPr>
+                        <a:t>Postgres</a:t>
+                      </a:r>
+                      <a:endParaRPr lang="en-US" sz="1200" dirty="0">
+                        <a:latin typeface="Segoe UI" charset="0"/>
+                        <a:ea typeface="Segoe UI" charset="0"/>
+                        <a:cs typeface="Segoe UI" charset="0"/>
+                      </a:endParaRPr>
+                    </a:p>
+                  </a:txBody>
+                  <a:tcPr marL="91440" marR="91440" marT="45720" marB="45720" anchor="ctr">
+                    <a:lnL w="0" cap="flat" cmpd="sng" algn="ctr">
+                      <a:solidFill>
+                        <a:srgbClr val="0A0A14"/>
+                      </a:solidFill>
+                      <a:prstDash val="solid"/>
+                      <a:round/>
+                      <a:headEnd type="none" w="med" len="med"/>
+                      <a:tailEnd type="none" w="med" len="med"/>
+                    </a:lnL>
+                    <a:lnR w="0" cap="flat" cmpd="sng" algn="ctr">
+                      <a:solidFill>
+                        <a:srgbClr val="0A0A14"/>
+                      </a:solidFill>
+                      <a:prstDash val="solid"/>
+                      <a:round/>
+                      <a:headEnd type="none" w="med" len="med"/>
+                      <a:tailEnd type="none" w="med" len="med"/>
+                    </a:lnR>
+                    <a:lnT w="0" cap="flat" cmpd="sng" algn="ctr">
+                      <a:solidFill>
+                        <a:srgbClr val="0A0A14"/>
+                      </a:solidFill>
+                      <a:prstDash val="solid"/>
+                      <a:round/>
+                      <a:headEnd type="none" w="med" len="med"/>
+                      <a:tailEnd type="none" w="med" len="med"/>
+                    </a:lnT>
+                    <a:lnB w="6350" cap="flat" cmpd="sng" algn="ctr">
+                      <a:solidFill>
+                        <a:srgbClr val="2A2A3E"/>
+                      </a:solidFill>
+                      <a:prstDash val="solid"/>
+                      <a:round/>
+                      <a:headEnd type="none" w="med" len="med"/>
+                      <a:tailEnd type="none" w="med" len="med"/>
+                    </a:lnB>
+                    <a:solidFill>
+                      <a:srgbClr val="0A0A14"/>
+                    </a:solidFill>
+                  </a:tcPr>
+                </a:tc>
+                <a:tc>
+                  <a:txBody>
+                    <a:bodyPr/>
+                    <a:lstStyle/>
+                    <a:p>
+                      <a:pPr indent="0" marL="0">
+                        <a:buNone/>
+                      </a:pPr>
+                      <a:r>
+                        <a:rPr lang="en-US" sz="1200" dirty="0">
+                          <a:solidFill>
+                            <a:srgbClr val="FFFFFF"/>
+                          </a:solidFill>
+                          <a:latin typeface="Segoe UI" pitchFamily="34" charset="0"/>
+                          <a:ea typeface="Segoe UI" pitchFamily="34" charset="-122"/>
+                          <a:cs typeface="Segoe UI" pitchFamily="34" charset="-120"/>
+                        </a:rPr>
+                        <a:t>postgres-exporter + com.dynatrace.extension.otel-postgres Hub extension</a:t>
+                      </a:r>
+                      <a:endParaRPr lang="en-US" sz="1200" dirty="0">
+                        <a:latin typeface="Segoe UI" charset="0"/>
+                        <a:ea typeface="Segoe UI" charset="0"/>
+                        <a:cs typeface="Segoe UI" charset="0"/>
+                      </a:endParaRPr>
+                    </a:p>
+                  </a:txBody>
+                  <a:tcPr marL="91440" marR="91440" marT="45720" marB="45720" anchor="ctr">
+                    <a:lnL w="0" cap="flat" cmpd="sng" algn="ctr">
+                      <a:solidFill>
+                        <a:srgbClr val="0A0A14"/>
+                      </a:solidFill>
+                      <a:prstDash val="solid"/>
+                      <a:round/>
+                      <a:headEnd type="none" w="med" len="med"/>
+                      <a:tailEnd type="none" w="med" len="med"/>
+                    </a:lnL>
+                    <a:lnR w="0" cap="flat" cmpd="sng" algn="ctr">
+                      <a:solidFill>
+                        <a:srgbClr val="0A0A14"/>
+                      </a:solidFill>
+                      <a:prstDash val="solid"/>
+                      <a:round/>
+                      <a:headEnd type="none" w="med" len="med"/>
+                      <a:tailEnd type="none" w="med" len="med"/>
+                    </a:lnR>
+                    <a:lnT w="0" cap="flat" cmpd="sng" algn="ctr">
+                      <a:solidFill>
+                        <a:srgbClr val="0A0A14"/>
+                      </a:solidFill>
+                      <a:prstDash val="solid"/>
+                      <a:round/>
+                      <a:headEnd type="none" w="med" len="med"/>
+                      <a:tailEnd type="none" w="med" len="med"/>
+                    </a:lnT>
+                    <a:lnB w="6350" cap="flat" cmpd="sng" algn="ctr">
+                      <a:solidFill>
+                        <a:srgbClr val="2A2A3E"/>
+                      </a:solidFill>
+                      <a:prstDash val="solid"/>
+                      <a:round/>
+                      <a:headEnd type="none" w="med" len="med"/>
+                      <a:tailEnd type="none" w="med" len="med"/>
+                    </a:lnB>
+                    <a:solidFill>
+                      <a:srgbClr val="0A0A14"/>
+                    </a:solidFill>
+                  </a:tcPr>
+                </a:tc>
+                <a:tc>
+                  <a:txBody>
+                    <a:bodyPr/>
+                    <a:lstStyle/>
+                    <a:p>
+                      <a:pPr indent="0" marL="0">
+                        <a:buNone/>
+                      </a:pPr>
+                      <a:r>
+                        <a:rPr lang="en-US" sz="1200" dirty="0">
+                          <a:solidFill>
+                            <a:srgbClr val="FFFFFF"/>
+                          </a:solidFill>
+                          <a:latin typeface="Segoe UI" pitchFamily="34" charset="0"/>
+                          <a:ea typeface="Segoe UI" pitchFamily="34" charset="-122"/>
+                          <a:cs typeface="Segoe UI" pitchFamily="34" charset="-120"/>
+                        </a:rPr>
+                        <a:t>postgres.xact_commit, postgres.deadlocks, postgres.blks_hit</a:t>
+                      </a:r>
+                      <a:endParaRPr lang="en-US" sz="1200" dirty="0">
+                        <a:latin typeface="Segoe UI" charset="0"/>
+                        <a:ea typeface="Segoe UI" charset="0"/>
+                        <a:cs typeface="Segoe UI" charset="0"/>
+                      </a:endParaRPr>
+                    </a:p>
+                  </a:txBody>
+                  <a:tcPr marL="91440" marR="91440" marT="45720" marB="45720" anchor="ctr">
+                    <a:lnL w="0" cap="flat" cmpd="sng" algn="ctr">
+                      <a:solidFill>
+                        <a:srgbClr val="0A0A14"/>
+                      </a:solidFill>
+                      <a:prstDash val="solid"/>
+                      <a:round/>
+                      <a:headEnd type="none" w="med" len="med"/>
+                      <a:tailEnd type="none" w="med" len="med"/>
+                    </a:lnL>
+                    <a:lnR w="0" cap="flat" cmpd="sng" algn="ctr">
+                      <a:solidFill>
+                        <a:srgbClr val="0A0A14"/>
+                      </a:solidFill>
+                      <a:prstDash val="solid"/>
+                      <a:round/>
+                      <a:headEnd type="none" w="med" len="med"/>
+                      <a:tailEnd type="none" w="med" len="med"/>
+                    </a:lnR>
+                    <a:lnT w="0" cap="flat" cmpd="sng" algn="ctr">
+                      <a:solidFill>
+                        <a:srgbClr val="0A0A14"/>
+                      </a:solidFill>
+                      <a:prstDash val="solid"/>
+                      <a:round/>
+                      <a:headEnd type="none" w="med" len="med"/>
+                      <a:tailEnd type="none" w="med" len="med"/>
+                    </a:lnT>
+                    <a:lnB w="6350" cap="flat" cmpd="sng" algn="ctr">
+                      <a:solidFill>
+                        <a:srgbClr val="2A2A3E"/>
+                      </a:solidFill>
+                      <a:prstDash val="solid"/>
+                      <a:round/>
+                      <a:headEnd type="none" w="med" len="med"/>
+                      <a:tailEnd type="none" w="med" len="med"/>
+                    </a:lnB>
+                    <a:solidFill>
+                      <a:srgbClr val="0A0A14"/>
+                    </a:solidFill>
+                  </a:tcPr>
+                </a:tc>
+              </a:tr>
+              <a:tr h="786384">
+                <a:tc>
+                  <a:txBody>
+                    <a:bodyPr/>
+                    <a:lstStyle/>
+                    <a:p>
+                      <a:pPr indent="0" marL="0">
+                        <a:buNone/>
+                      </a:pPr>
+                      <a:r>
+                        <a:rPr lang="en-US" sz="1200" dirty="0">
+                          <a:solidFill>
+                            <a:srgbClr val="FFFFFF"/>
+                          </a:solidFill>
+                          <a:latin typeface="Segoe UI" pitchFamily="34" charset="0"/>
+                          <a:ea typeface="Segoe UI" pitchFamily="34" charset="-122"/>
+                          <a:cs typeface="Segoe UI" pitchFamily="34" charset="-120"/>
+                        </a:rPr>
+                        <a:t>Kafka</a:t>
+                      </a:r>
+                      <a:endParaRPr lang="en-US" sz="1200" dirty="0">
+                        <a:latin typeface="Segoe UI" charset="0"/>
+                        <a:ea typeface="Segoe UI" charset="0"/>
+                        <a:cs typeface="Segoe UI" charset="0"/>
+                      </a:endParaRPr>
+                    </a:p>
+                  </a:txBody>
+                  <a:tcPr marL="91440" marR="91440" marT="45720" marB="45720" anchor="ctr">
+                    <a:lnL w="0" cap="flat" cmpd="sng" algn="ctr">
+                      <a:solidFill>
+                        <a:srgbClr val="0A0A14"/>
+                      </a:solidFill>
+                      <a:prstDash val="solid"/>
+                      <a:round/>
+                      <a:headEnd type="none" w="med" len="med"/>
+                      <a:tailEnd type="none" w="med" len="med"/>
+                    </a:lnL>
+                    <a:lnR w="0" cap="flat" cmpd="sng" algn="ctr">
+                      <a:solidFill>
+                        <a:srgbClr val="0A0A14"/>
+                      </a:solidFill>
+                      <a:prstDash val="solid"/>
+                      <a:round/>
+                      <a:headEnd type="none" w="med" len="med"/>
+                      <a:tailEnd type="none" w="med" len="med"/>
+                    </a:lnR>
+                    <a:lnT w="0" cap="flat" cmpd="sng" algn="ctr">
+                      <a:solidFill>
+                        <a:srgbClr val="0A0A14"/>
+                      </a:solidFill>
+                      <a:prstDash val="solid"/>
+                      <a:round/>
+                      <a:headEnd type="none" w="med" len="med"/>
+                      <a:tailEnd type="none" w="med" len="med"/>
+                    </a:lnT>
+                    <a:lnB w="6350" cap="flat" cmpd="sng" algn="ctr">
+                      <a:solidFill>
+                        <a:srgbClr val="2A2A3E"/>
+                      </a:solidFill>
+                      <a:prstDash val="solid"/>
+                      <a:round/>
+                      <a:headEnd type="none" w="med" len="med"/>
+                      <a:tailEnd type="none" w="med" len="med"/>
+                    </a:lnB>
+                    <a:solidFill>
+                      <a:srgbClr val="0A0A14"/>
+                    </a:solidFill>
+                  </a:tcPr>
+                </a:tc>
+                <a:tc>
+                  <a:txBody>
+                    <a:bodyPr/>
+                    <a:lstStyle/>
+                    <a:p>
+                      <a:pPr indent="0" marL="0">
+                        <a:buNone/>
+                      </a:pPr>
+                      <a:r>
+                        <a:rPr lang="en-US" sz="1200" dirty="0">
+                          <a:solidFill>
+                            <a:srgbClr val="FFFFFF"/>
+                          </a:solidFill>
+                          <a:latin typeface="Segoe UI" pitchFamily="34" charset="0"/>
+                          <a:ea typeface="Segoe UI" pitchFamily="34" charset="-122"/>
+                          <a:cs typeface="Segoe UI" pitchFamily="34" charset="-120"/>
+                        </a:rPr>
+                        <a:t>OneAgent built-in Kafka sensor (auto-detects Apache Kafka JVM)</a:t>
+                      </a:r>
+                      <a:endParaRPr lang="en-US" sz="1200" dirty="0">
+                        <a:latin typeface="Segoe UI" charset="0"/>
+                        <a:ea typeface="Segoe UI" charset="0"/>
+                        <a:cs typeface="Segoe UI" charset="0"/>
+                      </a:endParaRPr>
+                    </a:p>
+                  </a:txBody>
+                  <a:tcPr marL="91440" marR="91440" marT="45720" marB="45720" anchor="ctr">
+                    <a:lnL w="0" cap="flat" cmpd="sng" algn="ctr">
+                      <a:solidFill>
+                        <a:srgbClr val="0A0A14"/>
+                      </a:solidFill>
+                      <a:prstDash val="solid"/>
+                      <a:round/>
+                      <a:headEnd type="none" w="med" len="med"/>
+                      <a:tailEnd type="none" w="med" len="med"/>
+                    </a:lnL>
+                    <a:lnR w="0" cap="flat" cmpd="sng" algn="ctr">
+                      <a:solidFill>
+                        <a:srgbClr val="0A0A14"/>
+                      </a:solidFill>
+                      <a:prstDash val="solid"/>
+                      <a:round/>
+                      <a:headEnd type="none" w="med" len="med"/>
+                      <a:tailEnd type="none" w="med" len="med"/>
+                    </a:lnR>
+                    <a:lnT w="0" cap="flat" cmpd="sng" algn="ctr">
+                      <a:solidFill>
+                        <a:srgbClr val="0A0A14"/>
+                      </a:solidFill>
+                      <a:prstDash val="solid"/>
+                      <a:round/>
+                      <a:headEnd type="none" w="med" len="med"/>
+                      <a:tailEnd type="none" w="med" len="med"/>
+                    </a:lnT>
+                    <a:lnB w="6350" cap="flat" cmpd="sng" algn="ctr">
+                      <a:solidFill>
+                        <a:srgbClr val="2A2A3E"/>
+                      </a:solidFill>
+                      <a:prstDash val="solid"/>
+                      <a:round/>
+                      <a:headEnd type="none" w="med" len="med"/>
+                      <a:tailEnd type="none" w="med" len="med"/>
+                    </a:lnB>
+                    <a:solidFill>
+                      <a:srgbClr val="0A0A14"/>
+                    </a:solidFill>
+                  </a:tcPr>
+                </a:tc>
+                <a:tc>
+                  <a:txBody>
+                    <a:bodyPr/>
+                    <a:lstStyle/>
+                    <a:p>
+                      <a:pPr indent="0" marL="0">
+                        <a:buNone/>
+                      </a:pPr>
+                      <a:r>
+                        <a:rPr lang="en-US" sz="1200" dirty="0">
+                          <a:solidFill>
+                            <a:srgbClr val="FFFFFF"/>
+                          </a:solidFill>
+                          <a:latin typeface="Segoe UI" pitchFamily="34" charset="0"/>
+                          <a:ea typeface="Segoe UI" pitchFamily="34" charset="-122"/>
+                          <a:cs typeface="Segoe UI" pitchFamily="34" charset="-120"/>
+                        </a:rPr>
+                        <a:t>kafka.consumer_group.lag, kafka.request.time.99p, kafka.purgatory.size</a:t>
+                      </a:r>
+                      <a:endParaRPr lang="en-US" sz="1200" dirty="0">
+                        <a:latin typeface="Segoe UI" charset="0"/>
+                        <a:ea typeface="Segoe UI" charset="0"/>
+                        <a:cs typeface="Segoe UI" charset="0"/>
+                      </a:endParaRPr>
+                    </a:p>
+                  </a:txBody>
+                  <a:tcPr marL="91440" marR="91440" marT="45720" marB="45720" anchor="ctr">
+                    <a:lnL w="0" cap="flat" cmpd="sng" algn="ctr">
+                      <a:solidFill>
+                        <a:srgbClr val="0A0A14"/>
+                      </a:solidFill>
+                      <a:prstDash val="solid"/>
+                      <a:round/>
+                      <a:headEnd type="none" w="med" len="med"/>
+                      <a:tailEnd type="none" w="med" len="med"/>
+                    </a:lnL>
+                    <a:lnR w="0" cap="flat" cmpd="sng" algn="ctr">
+                      <a:solidFill>
+                        <a:srgbClr val="0A0A14"/>
+                      </a:solidFill>
+                      <a:prstDash val="solid"/>
+                      <a:round/>
+                      <a:headEnd type="none" w="med" len="med"/>
+                      <a:tailEnd type="none" w="med" len="med"/>
+                    </a:lnR>
+                    <a:lnT w="0" cap="flat" cmpd="sng" algn="ctr">
+                      <a:solidFill>
+                        <a:srgbClr val="0A0A14"/>
+                      </a:solidFill>
+                      <a:prstDash val="solid"/>
+                      <a:round/>
+                      <a:headEnd type="none" w="med" len="med"/>
+                      <a:tailEnd type="none" w="med" len="med"/>
+                    </a:lnT>
+                    <a:lnB w="6350" cap="flat" cmpd="sng" algn="ctr">
+                      <a:solidFill>
+                        <a:srgbClr val="2A2A3E"/>
+                      </a:solidFill>
+                      <a:prstDash val="solid"/>
+                      <a:round/>
+                      <a:headEnd type="none" w="med" len="med"/>
+                      <a:tailEnd type="none" w="med" len="med"/>
+                    </a:lnB>
+                    <a:solidFill>
+                      <a:srgbClr val="0A0A14"/>
+                    </a:solidFill>
+                  </a:tcPr>
+                </a:tc>
+              </a:tr>
+            </a:tbl>
+          </a:graphicData>
+        </a:graphic>
+      </p:graphicFrame>
     </p:spTree>
   </p:cSld>
   <p:clrMapOvr>
@@ -7053,7 +7618,7 @@
                 <a:ea typeface="Segoe UI" pitchFamily="34" charset="-122"/>
                 <a:cs typeface="Segoe UI" pitchFamily="34" charset="-120"/>
               </a:rPr>
-              <a:t>Metric-first DQL</a:t>
+              <a:t>`endpoint.name` and the `GET /*` reality</a:t>
             </a:r>
             <a:endParaRPr lang="en-US" sz="3600" dirty="0"/>
           </a:p>
@@ -7118,160 +7683,100 @@
         <p:spPr>
           <a:xfrm>
             <a:off x="457200" y="1463040"/>
-            <a:ext cx="8229600" cy="2240280"/>
+            <a:ext cx="8229600" cy="1691640"/>
           </a:xfrm>
           <a:prstGeom prst="rect">
             <a:avLst/>
           </a:prstGeom>
-          <a:solidFill>
-            <a:srgbClr val="1A1A2E"/>
-          </a:solidFill>
+          <a:noFill/>
           <a:ln/>
         </p:spPr>
         <p:txBody>
-          <a:bodyPr wrap="square" rtlCol="0" anchor="t"/>
+          <a:bodyPr wrap="square" lIns="0" tIns="0" rIns="0" bIns="0" rtlCol="0" anchor="t"/>
           <a:lstStyle/>
           <a:p>
-            <a:pPr indent="0" marL="0">
-              <a:buNone/>
-            </a:pPr>
-            <a:r>
-              <a:rPr lang="en-US" sz="1100" dirty="0">
+            <a:pPr marL="342900" indent="-342900">
+              <a:lnSpc>
+                <a:spcPct val="120000"/>
+              </a:lnSpc>
+              <a:buSzPct val="100000"/>
+              <a:buChar char="•"/>
+            </a:pPr>
+            <a:r>
+              <a:rPr lang="en-US" sz="2000" dirty="0">
                 <a:solidFill>
                   <a:srgbClr val="FFFFFF"/>
                 </a:solidFill>
-                <a:latin typeface="Consolas" pitchFamily="34" charset="0"/>
-                <a:ea typeface="Consolas" pitchFamily="34" charset="-122"/>
-                <a:cs typeface="Consolas" pitchFamily="34" charset="-120"/>
-              </a:rPr>
-              <a:t>// Classic shape</a:t>
-            </a:r>
-            <a:endParaRPr lang="en-US" sz="1100" dirty="0"/>
-          </a:p>
-          <a:p>
-            <a:pPr indent="0" marL="0">
-              <a:buNone/>
-            </a:pPr>
-            <a:r>
-              <a:rPr lang="en-US" sz="1100" dirty="0">
+                <a:latin typeface="Segoe UI" pitchFamily="34" charset="0"/>
+                <a:ea typeface="Segoe UI" pitchFamily="34" charset="-122"/>
+                <a:cs typeface="Segoe UI" pitchFamily="34" charset="-120"/>
+              </a:rPr>
+              <a:t>endpoint.name derives from http.route on server spans</a:t>
+            </a:r>
+            <a:endParaRPr lang="en-US" sz="2000" dirty="0"/>
+          </a:p>
+          <a:p>
+            <a:pPr marL="342900" indent="-342900">
+              <a:lnSpc>
+                <a:spcPct val="120000"/>
+              </a:lnSpc>
+              <a:buSzPct val="100000"/>
+              <a:buChar char="•"/>
+            </a:pPr>
+            <a:r>
+              <a:rPr lang="en-US" sz="2000" dirty="0">
                 <a:solidFill>
                   <a:srgbClr val="FFFFFF"/>
                 </a:solidFill>
-                <a:latin typeface="Consolas" pitchFamily="34" charset="0"/>
-                <a:ea typeface="Consolas" pitchFamily="34" charset="-122"/>
-                <a:cs typeface="Consolas" pitchFamily="34" charset="-120"/>
-              </a:rPr>
-              <a:t>fetch dt.entity.service</a:t>
-            </a:r>
-            <a:endParaRPr lang="en-US" sz="1100" dirty="0"/>
-          </a:p>
-          <a:p>
-            <a:pPr indent="0" marL="0">
-              <a:buNone/>
-            </a:pPr>
-            <a:r>
-              <a:rPr lang="en-US" sz="1100" dirty="0">
+                <a:latin typeface="Segoe UI" pitchFamily="34" charset="0"/>
+                <a:ea typeface="Segoe UI" pitchFamily="34" charset="-122"/>
+                <a:cs typeface="Segoe UI" pitchFamily="34" charset="-120"/>
+              </a:rPr>
+              <a:t>If http.route isn't set → fallback to &lt;METHOD&gt; /*</a:t>
+            </a:r>
+            <a:endParaRPr lang="en-US" sz="2000" dirty="0"/>
+          </a:p>
+          <a:p>
+            <a:pPr marL="342900" indent="-342900">
+              <a:lnSpc>
+                <a:spcPct val="120000"/>
+              </a:lnSpc>
+              <a:buSzPct val="100000"/>
+              <a:buChar char="•"/>
+            </a:pPr>
+            <a:r>
+              <a:rPr lang="en-US" sz="2000" dirty="0">
                 <a:solidFill>
                   <a:srgbClr val="FFFFFF"/>
                 </a:solidFill>
-                <a:latin typeface="Consolas" pitchFamily="34" charset="0"/>
-                <a:ea typeface="Consolas" pitchFamily="34" charset="-122"/>
-                <a:cs typeface="Consolas" pitchFamily="34" charset="-120"/>
-              </a:rPr>
-              <a:t>| filter entity.name == "orders-sdv2 -- orders-demo"</a:t>
-            </a:r>
-            <a:endParaRPr lang="en-US" sz="1100" dirty="0"/>
-          </a:p>
-          <a:p>
-            <a:pPr indent="0" marL="0">
-              <a:buNone/>
-            </a:pPr>
-            <a:r>
-              <a:rPr lang="en-US" sz="1100" dirty="0">
+                <a:latin typeface="Segoe UI" pitchFamily="34" charset="0"/>
+                <a:ea typeface="Segoe UI" pitchFamily="34" charset="-122"/>
+                <a:cs typeface="Segoe UI" pitchFamily="34" charset="-120"/>
+              </a:rPr>
+              <a:t>Spring MVC + OneAgent + orders-demo today → every endpoint is GET /*</a:t>
+            </a:r>
+            <a:endParaRPr lang="en-US" sz="2000" dirty="0"/>
+          </a:p>
+          <a:p>
+            <a:pPr marL="342900" indent="-342900">
+              <a:lnSpc>
+                <a:spcPct val="120000"/>
+              </a:lnSpc>
+              <a:buSzPct val="100000"/>
+              <a:buChar char="•"/>
+            </a:pPr>
+            <a:r>
+              <a:rPr lang="en-US" sz="2000" dirty="0">
                 <a:solidFill>
                   <a:srgbClr val="FFFFFF"/>
                 </a:solidFill>
-                <a:latin typeface="Consolas" pitchFamily="34" charset="0"/>
-                <a:ea typeface="Consolas" pitchFamily="34" charset="-122"/>
-                <a:cs typeface="Consolas" pitchFamily="34" charset="-120"/>
-              </a:rPr>
-              <a:t>| lookup [timeseries count = sum(dt.service.request.count), by: {dt.entity.service}],</a:t>
-            </a:r>
-            <a:endParaRPr lang="en-US" sz="1100" dirty="0"/>
-          </a:p>
-          <a:p>
-            <a:pPr indent="0" marL="0">
-              <a:buNone/>
-            </a:pPr>
-            <a:r>
-              <a:rPr lang="en-US" sz="1100" dirty="0">
-                <a:solidFill>
-                  <a:srgbClr val="FFFFFF"/>
-                </a:solidFill>
-                <a:latin typeface="Consolas" pitchFamily="34" charset="0"/>
-                <a:ea typeface="Consolas" pitchFamily="34" charset="-122"/>
-                <a:cs typeface="Consolas" pitchFamily="34" charset="-120"/>
-              </a:rPr>
-              <a:t>    sourceField: id, lookupField: dt.entity.service</a:t>
-            </a:r>
-            <a:endParaRPr lang="en-US" sz="1100" dirty="0"/>
-          </a:p>
-          <a:p>
-            <a:pPr indent="0" marL="0">
-              <a:buNone/>
-            </a:pPr>
-            <a:endParaRPr lang="en-US" sz="1100" dirty="0"/>
-          </a:p>
-          <a:p>
-            <a:pPr indent="0" marL="0">
-              <a:buNone/>
-            </a:pPr>
-            <a:r>
-              <a:rPr lang="en-US" sz="1100" dirty="0">
-                <a:solidFill>
-                  <a:srgbClr val="FFFFFF"/>
-                </a:solidFill>
-                <a:latin typeface="Consolas" pitchFamily="34" charset="0"/>
-                <a:ea typeface="Consolas" pitchFamily="34" charset="-122"/>
-                <a:cs typeface="Consolas" pitchFamily="34" charset="-120"/>
-              </a:rPr>
-              <a:t>// Latest shape</a:t>
-            </a:r>
-            <a:endParaRPr lang="en-US" sz="1100" dirty="0"/>
-          </a:p>
-          <a:p>
-            <a:pPr indent="0" marL="0">
-              <a:buNone/>
-            </a:pPr>
-            <a:r>
-              <a:rPr lang="en-US" sz="1100" dirty="0">
-                <a:solidFill>
-                  <a:srgbClr val="FFFFFF"/>
-                </a:solidFill>
-                <a:latin typeface="Consolas" pitchFamily="34" charset="0"/>
-                <a:ea typeface="Consolas" pitchFamily="34" charset="-122"/>
-                <a:cs typeface="Consolas" pitchFamily="34" charset="-120"/>
-              </a:rPr>
-              <a:t>timeseries count = sum(dt.service.request.count),</a:t>
-            </a:r>
-            <a:endParaRPr lang="en-US" sz="1100" dirty="0"/>
-          </a:p>
-          <a:p>
-            <a:pPr indent="0" marL="0">
-              <a:buNone/>
-            </a:pPr>
-            <a:r>
-              <a:rPr lang="en-US" sz="1100" dirty="0">
-                <a:solidFill>
-                  <a:srgbClr val="FFFFFF"/>
-                </a:solidFill>
-                <a:latin typeface="Consolas" pitchFamily="34" charset="0"/>
-                <a:ea typeface="Consolas" pitchFamily="34" charset="-122"/>
-                <a:cs typeface="Consolas" pitchFamily="34" charset="-120"/>
-              </a:rPr>
-              <a:t>  filter: dt.service.name == "orders-sdv2 -- orders-demo"</a:t>
-            </a:r>
-            <a:endParaRPr lang="en-US" sz="1100" dirty="0"/>
+                <a:latin typeface="Segoe UI" pitchFamily="34" charset="0"/>
+                <a:ea typeface="Segoe UI" pitchFamily="34" charset="-122"/>
+                <a:cs typeface="Segoe UI" pitchFamily="34" charset="-120"/>
+              </a:rPr>
+              <a:t>Throughput and latency are still right. The labels are wrong.</a:t>
+            </a:r>
+            <a:endParaRPr lang="en-US" sz="2000" dirty="0"/>
           </a:p>
         </p:txBody>
       </p:sp>
@@ -7283,7 +7788,7 @@
         </p:nvSpPr>
         <p:spPr>
           <a:xfrm>
-            <a:off x="457200" y="3840480"/>
+            <a:off x="457200" y="3291840"/>
             <a:ext cx="8229600" cy="832104"/>
           </a:xfrm>
           <a:prstGeom prst="rect">
@@ -7300,15 +7805,110 @@
               <a:buNone/>
             </a:pPr>
             <a:r>
-              <a:rPr lang="en-US" sz="2000" dirty="0">
-                <a:solidFill>
-                  <a:srgbClr val="FFFFFF"/>
+              <a:rPr lang="en-US" sz="2000" b="1" dirty="0">
+                <a:solidFill>
+                  <a:srgbClr val="00A1E0"/>
                 </a:solidFill>
                 <a:latin typeface="Segoe UI" pitchFamily="34" charset="0"/>
                 <a:ea typeface="Segoe UI" pitchFamily="34" charset="-122"/>
                 <a:cs typeface="Segoe UI" pitchFamily="34" charset="-120"/>
               </a:rPr>
-              <a:t>Same answer. Fewer lines, fewer scanned records, stable across entity re-detection.</a:t>
+              <a:t>Fix today:</a:t>
+            </a:r>
+            <a:pPr indent="0" marL="0">
+              <a:buNone/>
+            </a:pPr>
+            <a:r>
+              <a:rPr lang="en-US" sz="2000" dirty="0">
+                <a:solidFill>
+                  <a:srgbClr val="FFFFFF"/>
+                </a:solidFill>
+                <a:latin typeface="Segoe UI" pitchFamily="34" charset="0"/>
+                <a:ea typeface="Segoe UI" pitchFamily="34" charset="-122"/>
+                <a:cs typeface="Segoe UI" pitchFamily="34" charset="-120"/>
+              </a:rPr>
+              <a:t> Settings → Service detection → URL path pattern matching (SDv1 and SDv2).</a:t>
+            </a:r>
+            <a:endParaRPr lang="en-US" sz="2000" dirty="0"/>
+          </a:p>
+        </p:txBody>
+      </p:sp>
+      <p:sp>
+        <p:nvSpPr>
+          <p:cNvPr id="7" name="Text 5"/>
+          <p:cNvSpPr/>
+          <p:nvPr/>
+        </p:nvSpPr>
+        <p:spPr>
+          <a:xfrm>
+            <a:off x="457200" y="4306824"/>
+            <a:ext cx="8229600" cy="448056"/>
+          </a:xfrm>
+          <a:prstGeom prst="rect">
+            <a:avLst/>
+          </a:prstGeom>
+          <a:noFill/>
+          <a:ln/>
+        </p:spPr>
+        <p:txBody>
+          <a:bodyPr wrap="square" lIns="0" tIns="0" rIns="0" bIns="0" rtlCol="0" anchor="t"/>
+          <a:lstStyle/>
+          <a:p>
+            <a:pPr indent="0" marL="0">
+              <a:buNone/>
+            </a:pPr>
+            <a:r>
+              <a:rPr lang="en-US" sz="2000" b="1" dirty="0">
+                <a:solidFill>
+                  <a:srgbClr val="00A1E0"/>
+                </a:solidFill>
+                <a:latin typeface="Segoe UI" pitchFamily="34" charset="0"/>
+                <a:ea typeface="Segoe UI" pitchFamily="34" charset="-122"/>
+                <a:cs typeface="Segoe UI" pitchFamily="34" charset="-120"/>
+              </a:rPr>
+              <a:t>Automatic URL normalization coming.</a:t>
+            </a:r>
+            <a:pPr indent="0" marL="0">
+              <a:buNone/>
+            </a:pPr>
+            <a:r>
+              <a:rPr lang="en-US" sz="2000" dirty="0">
+                <a:solidFill>
+                  <a:srgbClr val="FFFFFF"/>
+                </a:solidFill>
+                <a:latin typeface="Segoe UI" pitchFamily="34" charset="0"/>
+                <a:ea typeface="Segoe UI" pitchFamily="34" charset="-122"/>
+                <a:cs typeface="Segoe UI" pitchFamily="34" charset="-120"/>
+              </a:rPr>
+              <a:t> Derives </a:t>
+            </a:r>
+            <a:pPr indent="0" marL="0">
+              <a:buNone/>
+            </a:pPr>
+            <a:r>
+              <a:rPr lang="en-US" sz="1800" dirty="0">
+                <a:solidFill>
+                  <a:srgbClr val="FFFFFF"/>
+                </a:solidFill>
+                <a:latin typeface="Consolas" pitchFamily="34" charset="0"/>
+                <a:ea typeface="Consolas" pitchFamily="34" charset="-122"/>
+                <a:cs typeface="Consolas" pitchFamily="34" charset="-120"/>
+              </a:rPr>
+              <a:t>http.route</a:t>
+            </a:r>
+            <a:pPr indent="0" marL="0">
+              <a:buNone/>
+            </a:pPr>
+            <a:r>
+              <a:rPr lang="en-US" sz="2000" dirty="0">
+                <a:solidFill>
+                  <a:srgbClr val="FFFFFF"/>
+                </a:solidFill>
+                <a:latin typeface="Segoe UI" pitchFamily="34" charset="0"/>
+                <a:ea typeface="Segoe UI" pitchFamily="34" charset="-122"/>
+                <a:cs typeface="Segoe UI" pitchFamily="34" charset="-120"/>
+              </a:rPr>
+              <a:t> by truncating at the first volatile segment (IDs, hashes, UUIDs). Classic-first rollout; SDv2 opt-in then default.</a:t>
             </a:r>
             <a:endParaRPr lang="en-US" sz="2000" dirty="0"/>
           </a:p>
@@ -7372,7 +7972,7 @@
                 <a:ea typeface="Segoe UI" pitchFamily="34" charset="-122"/>
                 <a:cs typeface="Segoe UI" pitchFamily="34" charset="-120"/>
               </a:rPr>
-              <a:t>What's coming</a:t>
+              <a:t>Metric-first DQL</a:t>
             </a:r>
             <a:endParaRPr lang="en-US" sz="3600" dirty="0"/>
           </a:p>
@@ -7437,7 +8037,173 @@
         <p:spPr>
           <a:xfrm>
             <a:off x="457200" y="1463040"/>
-            <a:ext cx="8229600" cy="3291840"/>
+            <a:ext cx="8229600" cy="2240280"/>
+          </a:xfrm>
+          <a:prstGeom prst="rect">
+            <a:avLst/>
+          </a:prstGeom>
+          <a:solidFill>
+            <a:srgbClr val="1A1A2E"/>
+          </a:solidFill>
+          <a:ln/>
+        </p:spPr>
+        <p:txBody>
+          <a:bodyPr wrap="square" rtlCol="0" anchor="t"/>
+          <a:lstStyle/>
+          <a:p>
+            <a:pPr indent="0" marL="0">
+              <a:buNone/>
+            </a:pPr>
+            <a:r>
+              <a:rPr lang="en-US" sz="1100" dirty="0">
+                <a:solidFill>
+                  <a:srgbClr val="FFFFFF"/>
+                </a:solidFill>
+                <a:latin typeface="Consolas" pitchFamily="34" charset="0"/>
+                <a:ea typeface="Consolas" pitchFamily="34" charset="-122"/>
+                <a:cs typeface="Consolas" pitchFamily="34" charset="-120"/>
+              </a:rPr>
+              <a:t>// Classic shape</a:t>
+            </a:r>
+            <a:endParaRPr lang="en-US" sz="1100" dirty="0"/>
+          </a:p>
+          <a:p>
+            <a:pPr indent="0" marL="0">
+              <a:buNone/>
+            </a:pPr>
+            <a:r>
+              <a:rPr lang="en-US" sz="1100" dirty="0">
+                <a:solidFill>
+                  <a:srgbClr val="FFFFFF"/>
+                </a:solidFill>
+                <a:latin typeface="Consolas" pitchFamily="34" charset="0"/>
+                <a:ea typeface="Consolas" pitchFamily="34" charset="-122"/>
+                <a:cs typeface="Consolas" pitchFamily="34" charset="-120"/>
+              </a:rPr>
+              <a:t>fetch dt.entity.service</a:t>
+            </a:r>
+            <a:endParaRPr lang="en-US" sz="1100" dirty="0"/>
+          </a:p>
+          <a:p>
+            <a:pPr indent="0" marL="0">
+              <a:buNone/>
+            </a:pPr>
+            <a:r>
+              <a:rPr lang="en-US" sz="1100" dirty="0">
+                <a:solidFill>
+                  <a:srgbClr val="FFFFFF"/>
+                </a:solidFill>
+                <a:latin typeface="Consolas" pitchFamily="34" charset="0"/>
+                <a:ea typeface="Consolas" pitchFamily="34" charset="-122"/>
+                <a:cs typeface="Consolas" pitchFamily="34" charset="-120"/>
+              </a:rPr>
+              <a:t>| filter entity.name == "orders-sdv2 -- orders-demo"</a:t>
+            </a:r>
+            <a:endParaRPr lang="en-US" sz="1100" dirty="0"/>
+          </a:p>
+          <a:p>
+            <a:pPr indent="0" marL="0">
+              <a:buNone/>
+            </a:pPr>
+            <a:r>
+              <a:rPr lang="en-US" sz="1100" dirty="0">
+                <a:solidFill>
+                  <a:srgbClr val="FFFFFF"/>
+                </a:solidFill>
+                <a:latin typeface="Consolas" pitchFamily="34" charset="0"/>
+                <a:ea typeface="Consolas" pitchFamily="34" charset="-122"/>
+                <a:cs typeface="Consolas" pitchFamily="34" charset="-120"/>
+              </a:rPr>
+              <a:t>| lookup [timeseries count = sum(dt.service.request.count), by: {dt.entity.service}],</a:t>
+            </a:r>
+            <a:endParaRPr lang="en-US" sz="1100" dirty="0"/>
+          </a:p>
+          <a:p>
+            <a:pPr indent="0" marL="0">
+              <a:buNone/>
+            </a:pPr>
+            <a:r>
+              <a:rPr lang="en-US" sz="1100" dirty="0">
+                <a:solidFill>
+                  <a:srgbClr val="FFFFFF"/>
+                </a:solidFill>
+                <a:latin typeface="Consolas" pitchFamily="34" charset="0"/>
+                <a:ea typeface="Consolas" pitchFamily="34" charset="-122"/>
+                <a:cs typeface="Consolas" pitchFamily="34" charset="-120"/>
+              </a:rPr>
+              <a:t>    sourceField: id, lookupField: dt.entity.service</a:t>
+            </a:r>
+            <a:endParaRPr lang="en-US" sz="1100" dirty="0"/>
+          </a:p>
+          <a:p>
+            <a:pPr indent="0" marL="0">
+              <a:buNone/>
+            </a:pPr>
+            <a:endParaRPr lang="en-US" sz="1100" dirty="0"/>
+          </a:p>
+          <a:p>
+            <a:pPr indent="0" marL="0">
+              <a:buNone/>
+            </a:pPr>
+            <a:r>
+              <a:rPr lang="en-US" sz="1100" dirty="0">
+                <a:solidFill>
+                  <a:srgbClr val="FFFFFF"/>
+                </a:solidFill>
+                <a:latin typeface="Consolas" pitchFamily="34" charset="0"/>
+                <a:ea typeface="Consolas" pitchFamily="34" charset="-122"/>
+                <a:cs typeface="Consolas" pitchFamily="34" charset="-120"/>
+              </a:rPr>
+              <a:t>// Latest shape</a:t>
+            </a:r>
+            <a:endParaRPr lang="en-US" sz="1100" dirty="0"/>
+          </a:p>
+          <a:p>
+            <a:pPr indent="0" marL="0">
+              <a:buNone/>
+            </a:pPr>
+            <a:r>
+              <a:rPr lang="en-US" sz="1100" dirty="0">
+                <a:solidFill>
+                  <a:srgbClr val="FFFFFF"/>
+                </a:solidFill>
+                <a:latin typeface="Consolas" pitchFamily="34" charset="0"/>
+                <a:ea typeface="Consolas" pitchFamily="34" charset="-122"/>
+                <a:cs typeface="Consolas" pitchFamily="34" charset="-120"/>
+              </a:rPr>
+              <a:t>timeseries count = sum(dt.service.request.count),</a:t>
+            </a:r>
+            <a:endParaRPr lang="en-US" sz="1100" dirty="0"/>
+          </a:p>
+          <a:p>
+            <a:pPr indent="0" marL="0">
+              <a:buNone/>
+            </a:pPr>
+            <a:r>
+              <a:rPr lang="en-US" sz="1100" dirty="0">
+                <a:solidFill>
+                  <a:srgbClr val="FFFFFF"/>
+                </a:solidFill>
+                <a:latin typeface="Consolas" pitchFamily="34" charset="0"/>
+                <a:ea typeface="Consolas" pitchFamily="34" charset="-122"/>
+                <a:cs typeface="Consolas" pitchFamily="34" charset="-120"/>
+              </a:rPr>
+              <a:t>  filter: dt.service.name == "orders-sdv2 -- orders-demo"</a:t>
+            </a:r>
+            <a:endParaRPr lang="en-US" sz="1100" dirty="0"/>
+          </a:p>
+        </p:txBody>
+      </p:sp>
+      <p:sp>
+        <p:nvSpPr>
+          <p:cNvPr id="6" name="Text 4"/>
+          <p:cNvSpPr/>
+          <p:nvPr/>
+        </p:nvSpPr>
+        <p:spPr>
+          <a:xfrm>
+            <a:off x="457200" y="3840480"/>
+            <a:ext cx="8229600" cy="832104"/>
           </a:xfrm>
           <a:prstGeom prst="rect">
             <a:avLst/>
@@ -7449,12 +8215,8 @@
           <a:bodyPr wrap="square" lIns="0" tIns="0" rIns="0" bIns="0" rtlCol="0" anchor="t"/>
           <a:lstStyle/>
           <a:p>
-            <a:pPr marL="342900" indent="-342900">
-              <a:lnSpc>
-                <a:spcPct val="120000"/>
-              </a:lnSpc>
-              <a:buSzPct val="100000"/>
-              <a:buChar char="•"/>
+            <a:pPr indent="0" marL="0">
+              <a:buNone/>
             </a:pPr>
             <a:r>
               <a:rPr lang="en-US" sz="2000" dirty="0">
@@ -7465,133 +8227,7 @@
                 <a:ea typeface="Segoe UI" pitchFamily="34" charset="-122"/>
                 <a:cs typeface="Segoe UI" pitchFamily="34" charset="-120"/>
               </a:rPr>
-              <a:t>Automatic URL normalization — closes the GET /* gap</a:t>
-            </a:r>
-            <a:endParaRPr lang="en-US" sz="2000" dirty="0"/>
-          </a:p>
-          <a:p>
-            <a:pPr marL="342900" indent="-342900">
-              <a:lnSpc>
-                <a:spcPct val="120000"/>
-              </a:lnSpc>
-              <a:buSzPct val="100000"/>
-              <a:buChar char="•"/>
-            </a:pPr>
-            <a:r>
-              <a:rPr lang="en-US" sz="2000" dirty="0">
-                <a:solidFill>
-                  <a:srgbClr val="FFFFFF"/>
-                </a:solidFill>
-                <a:latin typeface="Segoe UI" pitchFamily="34" charset="0"/>
-                <a:ea typeface="Segoe UI" pitchFamily="34" charset="-122"/>
-                <a:cs typeface="Segoe UI" pitchFamily="34" charset="-120"/>
-              </a:rPr>
-              <a:t>Pipeline-side naming in OpenPipeline — admin writes a rule, dt.service.name set on every span centrally</a:t>
-            </a:r>
-            <a:endParaRPr lang="en-US" sz="2000" dirty="0"/>
-          </a:p>
-          <a:p>
-            <a:pPr marL="342900" indent="-342900">
-              <a:lnSpc>
-                <a:spcPct val="120000"/>
-              </a:lnSpc>
-              <a:buSzPct val="100000"/>
-              <a:buChar char="•"/>
-            </a:pPr>
-            <a:r>
-              <a:rPr lang="en-US" sz="2000" dirty="0">
-                <a:solidFill>
-                  <a:srgbClr val="FFFFFF"/>
-                </a:solidFill>
-                <a:latin typeface="Segoe UI" pitchFamily="34" charset="0"/>
-                <a:ea typeface="Segoe UI" pitchFamily="34" charset="-122"/>
-                <a:cs typeface="Segoe UI" pitchFamily="34" charset="-120"/>
-              </a:rPr>
-              <a:t>SERVICE_DEPLOYMENT — per-env entity orthogonal to SERVICE; staging vs prod without splitting identity (maps to Datadog's service+env+version)</a:t>
-            </a:r>
-            <a:endParaRPr lang="en-US" sz="2000" dirty="0"/>
-          </a:p>
-          <a:p>
-            <a:pPr marL="342900" indent="-342900">
-              <a:lnSpc>
-                <a:spcPct val="120000"/>
-              </a:lnSpc>
-              <a:buSzPct val="100000"/>
-              <a:buChar char="•"/>
-            </a:pPr>
-            <a:r>
-              <a:rPr lang="en-US" sz="2000" dirty="0">
-                <a:solidFill>
-                  <a:srgbClr val="FFFFFF"/>
-                </a:solidFill>
-                <a:latin typeface="Segoe UI" pitchFamily="34" charset="0"/>
-                <a:ea typeface="Segoe UI" pitchFamily="34" charset="-122"/>
-                <a:cs typeface="Segoe UI" pitchFamily="34" charset="-120"/>
-              </a:rPr>
-              <a:t>Primary Fields as metric dimensions — k8s.cluster.name, tags become first-class on service metrics</a:t>
-            </a:r>
-            <a:endParaRPr lang="en-US" sz="2000" dirty="0"/>
-          </a:p>
-          <a:p>
-            <a:pPr marL="342900" indent="-342900">
-              <a:lnSpc>
-                <a:spcPct val="120000"/>
-              </a:lnSpc>
-              <a:buSzPct val="100000"/>
-              <a:buChar char="•"/>
-            </a:pPr>
-            <a:r>
-              <a:rPr lang="en-US" sz="2000" dirty="0">
-                <a:solidFill>
-                  <a:srgbClr val="FFFFFF"/>
-                </a:solidFill>
-                <a:latin typeface="Segoe UI" pitchFamily="34" charset="0"/>
-                <a:ea typeface="Segoe UI" pitchFamily="34" charset="-122"/>
-                <a:cs typeface="Segoe UI" pitchFamily="34" charset="-120"/>
-              </a:rPr>
-              <a:t>Services app rewire to timeseries-first — list + detail pages go query-led</a:t>
-            </a:r>
-            <a:endParaRPr lang="en-US" sz="2000" dirty="0"/>
-          </a:p>
-          <a:p>
-            <a:pPr marL="342900" indent="-342900">
-              <a:lnSpc>
-                <a:spcPct val="120000"/>
-              </a:lnSpc>
-              <a:buSzPct val="100000"/>
-              <a:buChar char="•"/>
-            </a:pPr>
-            <a:r>
-              <a:rPr lang="en-US" sz="2000" dirty="0">
-                <a:solidFill>
-                  <a:srgbClr val="FFFFFF"/>
-                </a:solidFill>
-                <a:latin typeface="Segoe UI" pitchFamily="34" charset="0"/>
-                <a:ea typeface="Segoe UI" pitchFamily="34" charset="-122"/>
-                <a:cs typeface="Segoe UI" pitchFamily="34" charset="-120"/>
-              </a:rPr>
-              <a:t>dt.service.database.* linked to real DB entities — future SDv2-for-OneAgent release; span data is already shaped correctly</a:t>
-            </a:r>
-            <a:endParaRPr lang="en-US" sz="2000" dirty="0"/>
-          </a:p>
-          <a:p>
-            <a:pPr marL="342900" indent="-342900">
-              <a:lnSpc>
-                <a:spcPct val="120000"/>
-              </a:lnSpc>
-              <a:buSzPct val="100000"/>
-              <a:buChar char="•"/>
-            </a:pPr>
-            <a:r>
-              <a:rPr lang="en-US" sz="2000" dirty="0">
-                <a:solidFill>
-                  <a:srgbClr val="FFFFFF"/>
-                </a:solidFill>
-                <a:latin typeface="Segoe UI" pitchFamily="34" charset="0"/>
-                <a:ea typeface="Segoe UI" pitchFamily="34" charset="-122"/>
-                <a:cs typeface="Segoe UI" pitchFamily="34" charset="-120"/>
-              </a:rPr>
-              <a:t>Messaging → broker entity — same idea, further out</a:t>
+              <a:t>Same answer. Fewer lines, fewer scanned records, stable across entity re-detection.</a:t>
             </a:r>
             <a:endParaRPr lang="en-US" sz="2000" dirty="0"/>
           </a:p>
@@ -7939,7 +8575,7 @@
                 <a:ea typeface="Segoe UI" pitchFamily="34" charset="-122"/>
                 <a:cs typeface="Segoe UI" pitchFamily="34" charset="-120"/>
               </a:rPr>
-              <a:t>What to do today</a:t>
+              <a:t>What's coming</a:t>
             </a:r>
             <a:endParaRPr lang="en-US" sz="3600" dirty="0"/>
           </a:p>
@@ -8032,7 +8668,7 @@
                 <a:ea typeface="Segoe UI" pitchFamily="34" charset="-122"/>
                 <a:cs typeface="Segoe UI" pitchFamily="34" charset="-120"/>
               </a:rPr>
-              <a:t>Set service.name on workloads you own — OTEL_SERVICE_NAME and OTEL_RESOURCE_ATTRIBUTES</a:t>
+              <a:t>Automatic URL normalization — closes the GET /* gap</a:t>
             </a:r>
             <a:endParaRPr lang="en-US" sz="2000" dirty="0"/>
           </a:p>
@@ -8053,7 +8689,7 @@
                 <a:ea typeface="Segoe UI" pitchFamily="34" charset="-122"/>
                 <a:cs typeface="Segoe UI" pitchFamily="34" charset="-120"/>
               </a:rPr>
-              <a:t>Write DQL metric-first — skip the entity table unless you need ownership or tags</a:t>
+              <a:t>Pipeline-side naming in OpenPipeline — admin writes a rule, dt.service.name set on every span centrally</a:t>
             </a:r>
             <a:endParaRPr lang="en-US" sz="2000" dirty="0"/>
           </a:p>
@@ -8074,7 +8710,7 @@
                 <a:ea typeface="Segoe UI" pitchFamily="34" charset="-122"/>
                 <a:cs typeface="Segoe UI" pitchFamily="34" charset="-120"/>
               </a:rPr>
-              <a:t>Don't invest new effort in Services Classic naming rules</a:t>
+              <a:t>SERVICE_DEPLOYMENT — per-env entity orthogonal to SERVICE; staging vs prod without splitting identity (maps to Datadog's service+env+version)</a:t>
             </a:r>
             <a:endParaRPr lang="en-US" sz="2000" dirty="0"/>
           </a:p>
@@ -8095,7 +8731,7 @@
                 <a:ea typeface="Segoe UI" pitchFamily="34" charset="-122"/>
                 <a:cs typeface="Segoe UI" pitchFamily="34" charset="-120"/>
               </a:rPr>
-              <a:t>Don't double down on splitting rules for per-env views — use dimensions now, SERVICE_DEPLOYMENT for the rest</a:t>
+              <a:t>Primary Fields as metric dimensions — k8s.cluster.name, tags become first-class on service metrics</a:t>
             </a:r>
             <a:endParaRPr lang="en-US" sz="2000" dirty="0"/>
           </a:p>
@@ -8116,7 +8752,49 @@
                 <a:ea typeface="Segoe UI" pitchFamily="34" charset="-122"/>
                 <a:cs typeface="Segoe UI" pitchFamily="34" charset="-120"/>
               </a:rPr>
-              <a:t>Pick names durable enough to survive the SDv2 move and the pipeline-naming move</a:t>
+              <a:t>Services app rewire to timeseries-first — list + detail pages go query-led</a:t>
+            </a:r>
+            <a:endParaRPr lang="en-US" sz="2000" dirty="0"/>
+          </a:p>
+          <a:p>
+            <a:pPr marL="342900" indent="-342900">
+              <a:lnSpc>
+                <a:spcPct val="120000"/>
+              </a:lnSpc>
+              <a:buSzPct val="100000"/>
+              <a:buChar char="•"/>
+            </a:pPr>
+            <a:r>
+              <a:rPr lang="en-US" sz="2000" dirty="0">
+                <a:solidFill>
+                  <a:srgbClr val="FFFFFF"/>
+                </a:solidFill>
+                <a:latin typeface="Segoe UI" pitchFamily="34" charset="0"/>
+                <a:ea typeface="Segoe UI" pitchFamily="34" charset="-122"/>
+                <a:cs typeface="Segoe UI" pitchFamily="34" charset="-120"/>
+              </a:rPr>
+              <a:t>dt.service.database.* linked to real DB entities — future SDv2-for-OneAgent release; span data is already shaped correctly</a:t>
+            </a:r>
+            <a:endParaRPr lang="en-US" sz="2000" dirty="0"/>
+          </a:p>
+          <a:p>
+            <a:pPr marL="342900" indent="-342900">
+              <a:lnSpc>
+                <a:spcPct val="120000"/>
+              </a:lnSpc>
+              <a:buSzPct val="100000"/>
+              <a:buChar char="•"/>
+            </a:pPr>
+            <a:r>
+              <a:rPr lang="en-US" sz="2000" dirty="0">
+                <a:solidFill>
+                  <a:srgbClr val="FFFFFF"/>
+                </a:solidFill>
+                <a:latin typeface="Segoe UI" pitchFamily="34" charset="0"/>
+                <a:ea typeface="Segoe UI" pitchFamily="34" charset="-122"/>
+                <a:cs typeface="Segoe UI" pitchFamily="34" charset="-120"/>
+              </a:rPr>
+              <a:t>Messaging → broker entity — same idea, further out</a:t>
             </a:r>
             <a:endParaRPr lang="en-US" sz="2000" dirty="0"/>
           </a:p>
@@ -8180,7 +8858,7 @@
                 <a:ea typeface="Segoe UI" pitchFamily="34" charset="-122"/>
                 <a:cs typeface="Segoe UI" pitchFamily="34" charset="-120"/>
               </a:rPr>
-              <a:t>See it live</a:t>
+              <a:t>What to do today</a:t>
             </a:r>
             <a:endParaRPr lang="en-US" sz="3600" dirty="0"/>
           </a:p>
@@ -8245,6 +8923,247 @@
         <p:spPr>
           <a:xfrm>
             <a:off x="457200" y="1463040"/>
+            <a:ext cx="8229600" cy="3291840"/>
+          </a:xfrm>
+          <a:prstGeom prst="rect">
+            <a:avLst/>
+          </a:prstGeom>
+          <a:noFill/>
+          <a:ln/>
+        </p:spPr>
+        <p:txBody>
+          <a:bodyPr wrap="square" lIns="0" tIns="0" rIns="0" bIns="0" rtlCol="0" anchor="t"/>
+          <a:lstStyle/>
+          <a:p>
+            <a:pPr marL="342900" indent="-342900">
+              <a:lnSpc>
+                <a:spcPct val="120000"/>
+              </a:lnSpc>
+              <a:buSzPct val="100000"/>
+              <a:buChar char="•"/>
+            </a:pPr>
+            <a:r>
+              <a:rPr lang="en-US" sz="2000" dirty="0">
+                <a:solidFill>
+                  <a:srgbClr val="FFFFFF"/>
+                </a:solidFill>
+                <a:latin typeface="Segoe UI" pitchFamily="34" charset="0"/>
+                <a:ea typeface="Segoe UI" pitchFamily="34" charset="-122"/>
+                <a:cs typeface="Segoe UI" pitchFamily="34" charset="-120"/>
+              </a:rPr>
+              <a:t>Set service.name on workloads you own — OTEL_SERVICE_NAME and OTEL_RESOURCE_ATTRIBUTES</a:t>
+            </a:r>
+            <a:endParaRPr lang="en-US" sz="2000" dirty="0"/>
+          </a:p>
+          <a:p>
+            <a:pPr marL="342900" indent="-342900">
+              <a:lnSpc>
+                <a:spcPct val="120000"/>
+              </a:lnSpc>
+              <a:buSzPct val="100000"/>
+              <a:buChar char="•"/>
+            </a:pPr>
+            <a:r>
+              <a:rPr lang="en-US" sz="2000" dirty="0">
+                <a:solidFill>
+                  <a:srgbClr val="FFFFFF"/>
+                </a:solidFill>
+                <a:latin typeface="Segoe UI" pitchFamily="34" charset="0"/>
+                <a:ea typeface="Segoe UI" pitchFamily="34" charset="-122"/>
+                <a:cs typeface="Segoe UI" pitchFamily="34" charset="-120"/>
+              </a:rPr>
+              <a:t>Write DQL metric-first — skip the entity table unless you need ownership or tags</a:t>
+            </a:r>
+            <a:endParaRPr lang="en-US" sz="2000" dirty="0"/>
+          </a:p>
+          <a:p>
+            <a:pPr marL="342900" indent="-342900">
+              <a:lnSpc>
+                <a:spcPct val="120000"/>
+              </a:lnSpc>
+              <a:buSzPct val="100000"/>
+              <a:buChar char="•"/>
+            </a:pPr>
+            <a:r>
+              <a:rPr lang="en-US" sz="2000" dirty="0">
+                <a:solidFill>
+                  <a:srgbClr val="FFFFFF"/>
+                </a:solidFill>
+                <a:latin typeface="Segoe UI" pitchFamily="34" charset="0"/>
+                <a:ea typeface="Segoe UI" pitchFamily="34" charset="-122"/>
+                <a:cs typeface="Segoe UI" pitchFamily="34" charset="-120"/>
+              </a:rPr>
+              <a:t>Don't invest new effort in Services Classic naming rules</a:t>
+            </a:r>
+            <a:endParaRPr lang="en-US" sz="2000" dirty="0"/>
+          </a:p>
+          <a:p>
+            <a:pPr marL="342900" indent="-342900">
+              <a:lnSpc>
+                <a:spcPct val="120000"/>
+              </a:lnSpc>
+              <a:buSzPct val="100000"/>
+              <a:buChar char="•"/>
+            </a:pPr>
+            <a:r>
+              <a:rPr lang="en-US" sz="2000" dirty="0">
+                <a:solidFill>
+                  <a:srgbClr val="FFFFFF"/>
+                </a:solidFill>
+                <a:latin typeface="Segoe UI" pitchFamily="34" charset="0"/>
+                <a:ea typeface="Segoe UI" pitchFamily="34" charset="-122"/>
+                <a:cs typeface="Segoe UI" pitchFamily="34" charset="-120"/>
+              </a:rPr>
+              <a:t>Don't double down on splitting rules for per-env views — use dimensions now, SERVICE_DEPLOYMENT for the rest</a:t>
+            </a:r>
+            <a:endParaRPr lang="en-US" sz="2000" dirty="0"/>
+          </a:p>
+          <a:p>
+            <a:pPr marL="342900" indent="-342900">
+              <a:lnSpc>
+                <a:spcPct val="120000"/>
+              </a:lnSpc>
+              <a:buSzPct val="100000"/>
+              <a:buChar char="•"/>
+            </a:pPr>
+            <a:r>
+              <a:rPr lang="en-US" sz="2000" dirty="0">
+                <a:solidFill>
+                  <a:srgbClr val="FFFFFF"/>
+                </a:solidFill>
+                <a:latin typeface="Segoe UI" pitchFamily="34" charset="0"/>
+                <a:ea typeface="Segoe UI" pitchFamily="34" charset="-122"/>
+                <a:cs typeface="Segoe UI" pitchFamily="34" charset="-120"/>
+              </a:rPr>
+              <a:t>Pick names durable enough to survive the SDv2 move and the pipeline-naming move</a:t>
+            </a:r>
+            <a:endParaRPr lang="en-US" sz="2000" dirty="0"/>
+          </a:p>
+        </p:txBody>
+      </p:sp>
+    </p:spTree>
+  </p:cSld>
+  <p:clrMapOvr>
+    <a:masterClrMapping/>
+  </p:clrMapOvr>
+</p:sld>
+</file>
+
+<file path=ppt/slides/slide22.xml><?xml version="1.0" encoding="utf-8"?>
+<p:sld xmlns:a="http://schemas.openxmlformats.org/drawingml/2006/main" xmlns:r="http://schemas.openxmlformats.org/officeDocument/2006/relationships" xmlns:p="http://schemas.openxmlformats.org/presentationml/2006/main">
+  <p:cSld name="Slide 22">
+    <p:spTree>
+      <p:nvGrpSpPr>
+        <p:cNvPr id="1" name=""/>
+        <p:cNvGrpSpPr/>
+        <p:nvPr/>
+      </p:nvGrpSpPr>
+      <p:grpSpPr>
+        <a:xfrm>
+          <a:off x="0" y="0"/>
+          <a:ext cx="0" cy="0"/>
+          <a:chOff x="0" y="0"/>
+          <a:chExt cx="0" cy="0"/>
+        </a:xfrm>
+      </p:grpSpPr>
+      <p:sp>
+        <p:nvSpPr>
+          <p:cNvPr id="2" name="Text 0"/>
+          <p:cNvSpPr/>
+          <p:nvPr/>
+        </p:nvSpPr>
+        <p:spPr>
+          <a:xfrm>
+            <a:off x="457200" y="457200"/>
+            <a:ext cx="8229600" cy="640080"/>
+          </a:xfrm>
+          <a:prstGeom prst="rect">
+            <a:avLst/>
+          </a:prstGeom>
+          <a:noFill/>
+          <a:ln/>
+        </p:spPr>
+        <p:txBody>
+          <a:bodyPr wrap="square" rtlCol="0" anchor="ctr"/>
+          <a:lstStyle/>
+          <a:p>
+            <a:pPr indent="0" marL="0">
+              <a:buNone/>
+            </a:pPr>
+            <a:r>
+              <a:rPr lang="en-US" sz="3600" b="1" dirty="0">
+                <a:solidFill>
+                  <a:srgbClr val="FFFFFF"/>
+                </a:solidFill>
+                <a:latin typeface="Segoe UI" pitchFamily="34" charset="0"/>
+                <a:ea typeface="Segoe UI" pitchFamily="34" charset="-122"/>
+                <a:cs typeface="Segoe UI" pitchFamily="34" charset="-120"/>
+              </a:rPr>
+              <a:t>See it live</a:t>
+            </a:r>
+            <a:endParaRPr lang="en-US" sz="3600" dirty="0"/>
+          </a:p>
+        </p:txBody>
+      </p:sp>
+      <p:sp>
+        <p:nvSpPr>
+          <p:cNvPr id="3" name="Shape 1"/>
+          <p:cNvSpPr/>
+          <p:nvPr/>
+        </p:nvSpPr>
+        <p:spPr>
+          <a:xfrm>
+            <a:off x="457200" y="1188720"/>
+            <a:ext cx="4114800" cy="54864"/>
+          </a:xfrm>
+          <a:prstGeom prst="rect">
+            <a:avLst/>
+          </a:prstGeom>
+          <a:solidFill>
+            <a:srgbClr val="00A1E0"/>
+          </a:solidFill>
+          <a:ln w="12700">
+            <a:solidFill>
+              <a:srgbClr val="00A1E0"/>
+            </a:solidFill>
+            <a:prstDash val="solid"/>
+          </a:ln>
+        </p:spPr>
+      </p:sp>
+      <p:sp>
+        <p:nvSpPr>
+          <p:cNvPr id="4" name="Shape 2"/>
+          <p:cNvSpPr/>
+          <p:nvPr/>
+        </p:nvSpPr>
+        <p:spPr>
+          <a:xfrm>
+            <a:off x="4572000" y="1188720"/>
+            <a:ext cx="4114800" cy="54864"/>
+          </a:xfrm>
+          <a:prstGeom prst="rect">
+            <a:avLst/>
+          </a:prstGeom>
+          <a:solidFill>
+            <a:srgbClr val="B455B6"/>
+          </a:solidFill>
+          <a:ln w="12700">
+            <a:solidFill>
+              <a:srgbClr val="B455B6"/>
+            </a:solidFill>
+            <a:prstDash val="solid"/>
+          </a:ln>
+        </p:spPr>
+      </p:sp>
+      <p:sp>
+        <p:nvSpPr>
+          <p:cNvPr id="5" name="Text 3"/>
+          <p:cNvSpPr/>
+          <p:nvPr/>
+        </p:nvSpPr>
+        <p:spPr>
+          <a:xfrm>
+            <a:off x="457200" y="1463040"/>
             <a:ext cx="8229600" cy="484632"/>
           </a:xfrm>
           <a:prstGeom prst="rect">
@@ -8311,7 +9230,7 @@
                 <a:ea typeface="Segoe UI" pitchFamily="34" charset="-122"/>
                 <a:cs typeface="Segoe UI" pitchFamily="34" charset="-120"/>
               </a:rPr>
-              <a:t>) — Questions 5-10</a:t>
+              <a:t>) — Questions 5 through 9c</a:t>
             </a:r>
             <a:endParaRPr lang="en-US" sz="2000" dirty="0"/>
           </a:p>
@@ -8326,7 +9245,7 @@
         <p:spPr>
           <a:xfrm>
             <a:off x="457200" y="2130552"/>
-            <a:ext cx="8229600" cy="2057400"/>
+            <a:ext cx="8229600" cy="2624328"/>
           </a:xfrm>
           <a:prstGeom prst="rect">
             <a:avLst/>
@@ -8418,6 +9337,48 @@
                 <a:cs typeface="Segoe UI" pitchFamily="34" charset="-120"/>
               </a:rPr>
               <a:t>Messaging + DB as dimensions on the caller</a:t>
+            </a:r>
+            <a:endParaRPr lang="en-US" sz="2000" dirty="0"/>
+          </a:p>
+          <a:p>
+            <a:pPr marL="342900" indent="-342900">
+              <a:lnSpc>
+                <a:spcPct val="120000"/>
+              </a:lnSpc>
+              <a:buSzPct val="100000"/>
+              <a:buChar char="•"/>
+            </a:pPr>
+            <a:r>
+              <a:rPr lang="en-US" sz="2000" dirty="0">
+                <a:solidFill>
+                  <a:srgbClr val="FFFFFF"/>
+                </a:solidFill>
+                <a:latin typeface="Segoe UI" pitchFamily="34" charset="0"/>
+                <a:ea typeface="Segoe UI" pitchFamily="34" charset="-122"/>
+                <a:cs typeface="Segoe UI" pitchFamily="34" charset="-120"/>
+              </a:rPr>
+              <a:t>Q9b — Postgres: client-side JDBC view vs. source-side postgres.* metrics from the extension</a:t>
+            </a:r>
+            <a:endParaRPr lang="en-US" sz="2000" dirty="0"/>
+          </a:p>
+          <a:p>
+            <a:pPr marL="342900" indent="-342900">
+              <a:lnSpc>
+                <a:spcPct val="120000"/>
+              </a:lnSpc>
+              <a:buSzPct val="100000"/>
+              <a:buChar char="•"/>
+            </a:pPr>
+            <a:r>
+              <a:rPr lang="en-US" sz="2000" dirty="0">
+                <a:solidFill>
+                  <a:srgbClr val="FFFFFF"/>
+                </a:solidFill>
+                <a:latin typeface="Segoe UI" pitchFamily="34" charset="0"/>
+                <a:ea typeface="Segoe UI" pitchFamily="34" charset="-122"/>
+                <a:cs typeface="Segoe UI" pitchFamily="34" charset="-120"/>
+              </a:rPr>
+              <a:t>Q9c — Kafka: client-side messaging.process.* vs. source-side kafka.* metrics from OneAgent's built-in sensor</a:t>
             </a:r>
             <a:endParaRPr lang="en-US" sz="2000" dirty="0"/>
           </a:p>

</xml_diff>